<commit_message>
feat: add community referrals and notifications
</commit_message>
<xml_diff>
--- a/CalGuard_Presentation_v2.pptx
+++ b/CalGuard_Presentation_v2.pptx
@@ -3749,7 +3749,7 @@
         </p:nvSpPr>
         <p:spPr>
           <a:xfrm>
-            <a:off x="457200" y="3931920"/>
+            <a:off x="457200" y="3977640"/>
             <a:ext cx="8229600" cy="960120"/>
           </a:xfrm>
           <a:prstGeom prst="rect">
@@ -20294,7 +20294,7 @@
         </p:nvSpPr>
         <p:spPr>
           <a:xfrm>
-            <a:off x="320040" y="2404872"/>
+            <a:off x="274320" y="2404872"/>
             <a:ext cx="1371600" cy="384048"/>
           </a:xfrm>
           <a:prstGeom prst="rect">
@@ -20309,7 +20309,7 @@
           <a:bodyPr/>
           <a:lstStyle/>
           <a:p>
-            <a:endParaRPr lang="en-US"/>
+            <a:endParaRPr lang="en-US" dirty="0"/>
           </a:p>
         </p:txBody>
       </p:sp>
@@ -27248,7 +27248,7 @@
         <p:spPr>
           <a:xfrm>
             <a:off x="457200" y="914400"/>
-            <a:ext cx="3931920" cy="3840480"/>
+            <a:ext cx="3931920" cy="2971800"/>
           </a:xfrm>
           <a:prstGeom prst="rect">
             <a:avLst/>
@@ -27556,13 +27556,13 @@
       </p:sp>
       <p:sp>
         <p:nvSpPr>
-          <p:cNvPr id="13" name="Shape 11"/>
-          <p:cNvSpPr/>
-          <p:nvPr/>
-        </p:nvSpPr>
-        <p:spPr>
-          <a:xfrm>
-            <a:off x="640080" y="2450592"/>
+          <p:cNvPr id="19" name="Shape 17"/>
+          <p:cNvSpPr/>
+          <p:nvPr/>
+        </p:nvSpPr>
+        <p:spPr>
+          <a:xfrm>
+            <a:off x="640080" y="2427732"/>
             <a:ext cx="128016" cy="128016"/>
           </a:xfrm>
           <a:prstGeom prst="ellipse">
@@ -27583,13 +27583,13 @@
       </p:sp>
       <p:sp>
         <p:nvSpPr>
-          <p:cNvPr id="14" name="Text 12"/>
-          <p:cNvSpPr/>
-          <p:nvPr/>
-        </p:nvSpPr>
-        <p:spPr>
-          <a:xfrm>
-            <a:off x="868680" y="2377440"/>
+          <p:cNvPr id="20" name="Text 18"/>
+          <p:cNvSpPr/>
+          <p:nvPr/>
+        </p:nvSpPr>
+        <p:spPr>
+          <a:xfrm>
+            <a:off x="868680" y="2354580"/>
             <a:ext cx="3337560" cy="301752"/>
           </a:xfrm>
           <a:prstGeom prst="rect">
@@ -27614,12 +27614,63 @@
                 <a:ea typeface="Calibri" pitchFamily="34" charset="-122"/>
                 <a:cs typeface="Calibri" pitchFamily="34" charset="-120"/>
               </a:rPr>
-              <a:t>AI coaching chatbot (Thai language)</a:t>
-            </a:r>
-            <a:r>
-              <a:rPr lang="en-US" sz="950" dirty="0"/>
-              <a:t> </a:t>
-            </a:r>
+              <a:t>Weight trend analysis via Linear Regression (sklearn)</a:t>
+            </a:r>
+            <a:endParaRPr lang="en-US" sz="950" dirty="0"/>
+          </a:p>
+        </p:txBody>
+      </p:sp>
+      <p:sp>
+        <p:nvSpPr>
+          <p:cNvPr id="21" name="Shape 19"/>
+          <p:cNvSpPr/>
+          <p:nvPr/>
+        </p:nvSpPr>
+        <p:spPr>
+          <a:xfrm>
+            <a:off x="640080" y="2759202"/>
+            <a:ext cx="128016" cy="128016"/>
+          </a:xfrm>
+          <a:prstGeom prst="ellipse">
+            <a:avLst/>
+          </a:prstGeom>
+          <a:solidFill>
+            <a:srgbClr val="10B981"/>
+          </a:solidFill>
+          <a:ln/>
+        </p:spPr>
+        <p:txBody>
+          <a:bodyPr/>
+          <a:lstStyle/>
+          <a:p>
+            <a:endParaRPr lang="en-US"/>
+          </a:p>
+        </p:txBody>
+      </p:sp>
+      <p:sp>
+        <p:nvSpPr>
+          <p:cNvPr id="22" name="Text 20"/>
+          <p:cNvSpPr/>
+          <p:nvPr/>
+        </p:nvSpPr>
+        <p:spPr>
+          <a:xfrm>
+            <a:off x="868680" y="2674620"/>
+            <a:ext cx="3337560" cy="301752"/>
+          </a:xfrm>
+          <a:prstGeom prst="rect">
+            <a:avLst/>
+          </a:prstGeom>
+          <a:noFill/>
+          <a:ln/>
+        </p:spPr>
+        <p:txBody>
+          <a:bodyPr wrap="square" lIns="0" tIns="0" rIns="0" bIns="0" rtlCol="0" anchor="ctr"/>
+          <a:lstStyle/>
+          <a:p>
+            <a:pPr marL="0" indent="0">
+              <a:buNone/>
+            </a:pPr>
             <a:r>
               <a:rPr lang="en-US" sz="950" dirty="0">
                 <a:solidFill>
@@ -27629,10 +27680,65 @@
                 <a:ea typeface="Calibri" pitchFamily="34" charset="-122"/>
                 <a:cs typeface="Calibri" pitchFamily="34" charset="-120"/>
               </a:rPr>
-              <a:t>using </a:t>
-            </a:r>
-            <a:r>
-              <a:rPr lang="en-SG" sz="950" dirty="0">
+              <a:t>Progress dashboard: calories, macros, weight, adherence</a:t>
+            </a:r>
+            <a:endParaRPr lang="en-US" sz="950" dirty="0"/>
+          </a:p>
+        </p:txBody>
+      </p:sp>
+      <p:sp>
+        <p:nvSpPr>
+          <p:cNvPr id="23" name="Shape 21"/>
+          <p:cNvSpPr/>
+          <p:nvPr/>
+        </p:nvSpPr>
+        <p:spPr>
+          <a:xfrm>
+            <a:off x="640080" y="3054096"/>
+            <a:ext cx="128016" cy="128016"/>
+          </a:xfrm>
+          <a:prstGeom prst="ellipse">
+            <a:avLst/>
+          </a:prstGeom>
+          <a:solidFill>
+            <a:srgbClr val="10B981"/>
+          </a:solidFill>
+          <a:ln/>
+        </p:spPr>
+        <p:txBody>
+          <a:bodyPr/>
+          <a:lstStyle/>
+          <a:p>
+            <a:endParaRPr lang="en-US"/>
+          </a:p>
+        </p:txBody>
+      </p:sp>
+      <p:sp>
+        <p:nvSpPr>
+          <p:cNvPr id="24" name="Text 22"/>
+          <p:cNvSpPr/>
+          <p:nvPr/>
+        </p:nvSpPr>
+        <p:spPr>
+          <a:xfrm>
+            <a:off x="868680" y="2994660"/>
+            <a:ext cx="3337560" cy="301752"/>
+          </a:xfrm>
+          <a:prstGeom prst="rect">
+            <a:avLst/>
+          </a:prstGeom>
+          <a:noFill/>
+          <a:ln/>
+        </p:spPr>
+        <p:txBody>
+          <a:bodyPr wrap="square" lIns="0" tIns="0" rIns="0" bIns="0" rtlCol="0" anchor="ctr"/>
+          <a:lstStyle/>
+          <a:p>
+            <a:pPr marL="0" indent="0">
+              <a:buNone/>
+            </a:pPr>
+            <a:r>
+              <a:rPr lang="en-US" sz="950" dirty="0">
                 <a:solidFill>
                   <a:srgbClr val="1A1A2E"/>
                 </a:solidFill>
@@ -27640,18 +27746,7 @@
                 <a:ea typeface="Calibri" pitchFamily="34" charset="-122"/>
                 <a:cs typeface="Calibri" pitchFamily="34" charset="-120"/>
               </a:rPr>
-              <a:t>Local</a:t>
-            </a:r>
-            <a:r>
-              <a:rPr lang="en-US" sz="950" dirty="0">
-                <a:solidFill>
-                  <a:srgbClr val="1A1A2E"/>
-                </a:solidFill>
-                <a:latin typeface="Calibri" pitchFamily="34" charset="0"/>
-                <a:ea typeface="Calibri" pitchFamily="34" charset="-122"/>
-                <a:cs typeface="Calibri" pitchFamily="34" charset="-120"/>
-              </a:rPr>
-              <a:t>LLMs DeepSeek-R1</a:t>
+              <a:t>RESTful API backend (FastAPI + PostgreSQL)</a:t>
             </a:r>
             <a:endParaRPr lang="en-US" sz="950" dirty="0"/>
           </a:p>
@@ -27659,13 +27754,13 @@
       </p:sp>
       <p:sp>
         <p:nvSpPr>
-          <p:cNvPr id="15" name="Shape 13"/>
-          <p:cNvSpPr/>
-          <p:nvPr/>
-        </p:nvSpPr>
-        <p:spPr>
-          <a:xfrm>
-            <a:off x="640080" y="2770632"/>
+          <p:cNvPr id="25" name="Shape 23"/>
+          <p:cNvSpPr/>
+          <p:nvPr/>
+        </p:nvSpPr>
+        <p:spPr>
+          <a:xfrm>
+            <a:off x="640080" y="3387852"/>
             <a:ext cx="128016" cy="128016"/>
           </a:xfrm>
           <a:prstGeom prst="ellipse">
@@ -27686,360 +27781,13 @@
       </p:sp>
       <p:sp>
         <p:nvSpPr>
-          <p:cNvPr id="16" name="Text 14"/>
-          <p:cNvSpPr/>
-          <p:nvPr/>
-        </p:nvSpPr>
-        <p:spPr>
-          <a:xfrm>
-            <a:off x="868680" y="2697480"/>
-            <a:ext cx="3337560" cy="301752"/>
-          </a:xfrm>
-          <a:prstGeom prst="rect">
-            <a:avLst/>
-          </a:prstGeom>
-          <a:noFill/>
-          <a:ln/>
-        </p:spPr>
-        <p:txBody>
-          <a:bodyPr wrap="square" lIns="0" tIns="0" rIns="0" bIns="0" rtlCol="0" anchor="ctr"/>
-          <a:lstStyle/>
-          <a:p>
-            <a:pPr marL="0" indent="0">
-              <a:buNone/>
-            </a:pPr>
-            <a:r>
-              <a:rPr lang="en-US" sz="950" dirty="0">
-                <a:solidFill>
-                  <a:srgbClr val="1A1A2E"/>
-                </a:solidFill>
-                <a:latin typeface="Calibri" pitchFamily="34" charset="0"/>
-                <a:ea typeface="Calibri" pitchFamily="34" charset="-122"/>
-                <a:cs typeface="Calibri" pitchFamily="34" charset="-120"/>
-              </a:rPr>
-              <a:t>Thai NLP food extraction from free text (pythainlp)</a:t>
-            </a:r>
-            <a:endParaRPr lang="en-US" sz="950" dirty="0"/>
-          </a:p>
-        </p:txBody>
-      </p:sp>
-      <p:sp>
-        <p:nvSpPr>
-          <p:cNvPr id="17" name="Shape 15"/>
-          <p:cNvSpPr/>
-          <p:nvPr/>
-        </p:nvSpPr>
-        <p:spPr>
-          <a:xfrm>
-            <a:off x="640080" y="3090672"/>
-            <a:ext cx="128016" cy="128016"/>
-          </a:xfrm>
-          <a:prstGeom prst="ellipse">
-            <a:avLst/>
-          </a:prstGeom>
-          <a:solidFill>
-            <a:srgbClr val="10B981"/>
-          </a:solidFill>
-          <a:ln/>
-        </p:spPr>
-        <p:txBody>
-          <a:bodyPr/>
-          <a:lstStyle/>
-          <a:p>
-            <a:endParaRPr lang="en-US"/>
-          </a:p>
-        </p:txBody>
-      </p:sp>
-      <p:sp>
-        <p:nvSpPr>
-          <p:cNvPr id="18" name="Text 16"/>
-          <p:cNvSpPr/>
-          <p:nvPr/>
-        </p:nvSpPr>
-        <p:spPr>
-          <a:xfrm>
-            <a:off x="868680" y="3017520"/>
-            <a:ext cx="3337560" cy="301752"/>
-          </a:xfrm>
-          <a:prstGeom prst="rect">
-            <a:avLst/>
-          </a:prstGeom>
-          <a:noFill/>
-          <a:ln/>
-        </p:spPr>
-        <p:txBody>
-          <a:bodyPr wrap="square" lIns="0" tIns="0" rIns="0" bIns="0" rtlCol="0" anchor="ctr"/>
-          <a:lstStyle/>
-          <a:p>
-            <a:pPr marL="0" indent="0">
-              <a:buNone/>
-            </a:pPr>
-            <a:r>
-              <a:rPr lang="en-US" sz="950" dirty="0">
-                <a:solidFill>
-                  <a:srgbClr val="1A1A2E"/>
-                </a:solidFill>
-                <a:latin typeface="Calibri" pitchFamily="34" charset="0"/>
-                <a:ea typeface="Calibri" pitchFamily="34" charset="-122"/>
-                <a:cs typeface="Calibri" pitchFamily="34" charset="-120"/>
-              </a:rPr>
-              <a:t>Hybrid food recommendation algorithm</a:t>
-            </a:r>
-            <a:endParaRPr lang="en-US" sz="950" dirty="0"/>
-          </a:p>
-          <a:p>
-            <a:pPr marL="0" indent="0">
-              <a:buNone/>
-            </a:pPr>
-            <a:r>
-              <a:rPr lang="en-US" sz="950" dirty="0">
-                <a:solidFill>
-                  <a:srgbClr val="1A1A2E"/>
-                </a:solidFill>
-                <a:latin typeface="Calibri" pitchFamily="34" charset="0"/>
-                <a:ea typeface="Calibri" pitchFamily="34" charset="-122"/>
-                <a:cs typeface="Calibri" pitchFamily="34" charset="-120"/>
-              </a:rPr>
-              <a:t>(NFS + Cosine Similarity + User Preference)</a:t>
-            </a:r>
-            <a:endParaRPr lang="en-US" sz="950" dirty="0"/>
-          </a:p>
-        </p:txBody>
-      </p:sp>
-      <p:sp>
-        <p:nvSpPr>
-          <p:cNvPr id="19" name="Shape 17"/>
-          <p:cNvSpPr/>
-          <p:nvPr/>
-        </p:nvSpPr>
-        <p:spPr>
-          <a:xfrm>
-            <a:off x="640080" y="3410712"/>
-            <a:ext cx="128016" cy="128016"/>
-          </a:xfrm>
-          <a:prstGeom prst="ellipse">
-            <a:avLst/>
-          </a:prstGeom>
-          <a:solidFill>
-            <a:srgbClr val="10B981"/>
-          </a:solidFill>
-          <a:ln/>
-        </p:spPr>
-        <p:txBody>
-          <a:bodyPr/>
-          <a:lstStyle/>
-          <a:p>
-            <a:endParaRPr lang="en-US"/>
-          </a:p>
-        </p:txBody>
-      </p:sp>
-      <p:sp>
-        <p:nvSpPr>
-          <p:cNvPr id="20" name="Text 18"/>
-          <p:cNvSpPr/>
-          <p:nvPr/>
-        </p:nvSpPr>
-        <p:spPr>
-          <a:xfrm>
-            <a:off x="868680" y="3337560"/>
-            <a:ext cx="3337560" cy="301752"/>
-          </a:xfrm>
-          <a:prstGeom prst="rect">
-            <a:avLst/>
-          </a:prstGeom>
-          <a:noFill/>
-          <a:ln/>
-        </p:spPr>
-        <p:txBody>
-          <a:bodyPr wrap="square" lIns="0" tIns="0" rIns="0" bIns="0" rtlCol="0" anchor="ctr"/>
-          <a:lstStyle/>
-          <a:p>
-            <a:pPr marL="0" indent="0">
-              <a:buNone/>
-            </a:pPr>
-            <a:r>
-              <a:rPr lang="en-US" sz="950" dirty="0">
-                <a:solidFill>
-                  <a:srgbClr val="1A1A2E"/>
-                </a:solidFill>
-                <a:latin typeface="Calibri" pitchFamily="34" charset="0"/>
-                <a:ea typeface="Calibri" pitchFamily="34" charset="-122"/>
-                <a:cs typeface="Calibri" pitchFamily="34" charset="-120"/>
-              </a:rPr>
-              <a:t>Weight trend analysis via Linear Regression (sklearn)</a:t>
-            </a:r>
-            <a:endParaRPr lang="en-US" sz="950" dirty="0"/>
-          </a:p>
-        </p:txBody>
-      </p:sp>
-      <p:sp>
-        <p:nvSpPr>
-          <p:cNvPr id="21" name="Shape 19"/>
-          <p:cNvSpPr/>
-          <p:nvPr/>
-        </p:nvSpPr>
-        <p:spPr>
-          <a:xfrm>
-            <a:off x="640080" y="3730752"/>
-            <a:ext cx="128016" cy="128016"/>
-          </a:xfrm>
-          <a:prstGeom prst="ellipse">
-            <a:avLst/>
-          </a:prstGeom>
-          <a:solidFill>
-            <a:srgbClr val="10B981"/>
-          </a:solidFill>
-          <a:ln/>
-        </p:spPr>
-        <p:txBody>
-          <a:bodyPr/>
-          <a:lstStyle/>
-          <a:p>
-            <a:endParaRPr lang="en-US"/>
-          </a:p>
-        </p:txBody>
-      </p:sp>
-      <p:sp>
-        <p:nvSpPr>
-          <p:cNvPr id="22" name="Text 20"/>
-          <p:cNvSpPr/>
-          <p:nvPr/>
-        </p:nvSpPr>
-        <p:spPr>
-          <a:xfrm>
-            <a:off x="868680" y="3657600"/>
-            <a:ext cx="3337560" cy="301752"/>
-          </a:xfrm>
-          <a:prstGeom prst="rect">
-            <a:avLst/>
-          </a:prstGeom>
-          <a:noFill/>
-          <a:ln/>
-        </p:spPr>
-        <p:txBody>
-          <a:bodyPr wrap="square" lIns="0" tIns="0" rIns="0" bIns="0" rtlCol="0" anchor="ctr"/>
-          <a:lstStyle/>
-          <a:p>
-            <a:pPr marL="0" indent="0">
-              <a:buNone/>
-            </a:pPr>
-            <a:r>
-              <a:rPr lang="en-US" sz="950" dirty="0">
-                <a:solidFill>
-                  <a:srgbClr val="1A1A2E"/>
-                </a:solidFill>
-                <a:latin typeface="Calibri" pitchFamily="34" charset="0"/>
-                <a:ea typeface="Calibri" pitchFamily="34" charset="-122"/>
-                <a:cs typeface="Calibri" pitchFamily="34" charset="-120"/>
-              </a:rPr>
-              <a:t>Progress dashboard: calories, macros, weight, adherence</a:t>
-            </a:r>
-            <a:endParaRPr lang="en-US" sz="950" dirty="0"/>
-          </a:p>
-        </p:txBody>
-      </p:sp>
-      <p:sp>
-        <p:nvSpPr>
-          <p:cNvPr id="23" name="Shape 21"/>
-          <p:cNvSpPr/>
-          <p:nvPr/>
-        </p:nvSpPr>
-        <p:spPr>
-          <a:xfrm>
-            <a:off x="640080" y="4050792"/>
-            <a:ext cx="128016" cy="128016"/>
-          </a:xfrm>
-          <a:prstGeom prst="ellipse">
-            <a:avLst/>
-          </a:prstGeom>
-          <a:solidFill>
-            <a:srgbClr val="10B981"/>
-          </a:solidFill>
-          <a:ln/>
-        </p:spPr>
-        <p:txBody>
-          <a:bodyPr/>
-          <a:lstStyle/>
-          <a:p>
-            <a:endParaRPr lang="en-US"/>
-          </a:p>
-        </p:txBody>
-      </p:sp>
-      <p:sp>
-        <p:nvSpPr>
-          <p:cNvPr id="24" name="Text 22"/>
-          <p:cNvSpPr/>
-          <p:nvPr/>
-        </p:nvSpPr>
-        <p:spPr>
-          <a:xfrm>
-            <a:off x="868680" y="3977640"/>
-            <a:ext cx="3337560" cy="301752"/>
-          </a:xfrm>
-          <a:prstGeom prst="rect">
-            <a:avLst/>
-          </a:prstGeom>
-          <a:noFill/>
-          <a:ln/>
-        </p:spPr>
-        <p:txBody>
-          <a:bodyPr wrap="square" lIns="0" tIns="0" rIns="0" bIns="0" rtlCol="0" anchor="ctr"/>
-          <a:lstStyle/>
-          <a:p>
-            <a:pPr marL="0" indent="0">
-              <a:buNone/>
-            </a:pPr>
-            <a:r>
-              <a:rPr lang="en-US" sz="950" dirty="0">
-                <a:solidFill>
-                  <a:srgbClr val="1A1A2E"/>
-                </a:solidFill>
-                <a:latin typeface="Calibri" pitchFamily="34" charset="0"/>
-                <a:ea typeface="Calibri" pitchFamily="34" charset="-122"/>
-                <a:cs typeface="Calibri" pitchFamily="34" charset="-120"/>
-              </a:rPr>
-              <a:t>RESTful API backend (FastAPI + PostgreSQL)</a:t>
-            </a:r>
-            <a:endParaRPr lang="en-US" sz="950" dirty="0"/>
-          </a:p>
-        </p:txBody>
-      </p:sp>
-      <p:sp>
-        <p:nvSpPr>
-          <p:cNvPr id="25" name="Shape 23"/>
-          <p:cNvSpPr/>
-          <p:nvPr/>
-        </p:nvSpPr>
-        <p:spPr>
-          <a:xfrm>
-            <a:off x="640080" y="4370832"/>
-            <a:ext cx="128016" cy="128016"/>
-          </a:xfrm>
-          <a:prstGeom prst="ellipse">
-            <a:avLst/>
-          </a:prstGeom>
-          <a:solidFill>
-            <a:srgbClr val="10B981"/>
-          </a:solidFill>
-          <a:ln/>
-        </p:spPr>
-        <p:txBody>
-          <a:bodyPr/>
-          <a:lstStyle/>
-          <a:p>
-            <a:endParaRPr lang="en-US"/>
-          </a:p>
-        </p:txBody>
-      </p:sp>
-      <p:sp>
-        <p:nvSpPr>
           <p:cNvPr id="26" name="Text 24"/>
           <p:cNvSpPr/>
           <p:nvPr/>
         </p:nvSpPr>
         <p:spPr>
           <a:xfrm>
-            <a:off x="868680" y="4297680"/>
+            <a:off x="868680" y="3314700"/>
             <a:ext cx="3337560" cy="301752"/>
           </a:xfrm>
           <a:prstGeom prst="rect">
@@ -28530,7 +28278,7 @@
           <a:bodyPr/>
           <a:lstStyle/>
           <a:p>
-            <a:endParaRPr lang="en-US"/>
+            <a:endParaRPr lang="en-US" dirty="0"/>
           </a:p>
         </p:txBody>
       </p:sp>
@@ -28624,68 +28372,6 @@
             <a:pPr marL="0" indent="0">
               <a:buNone/>
             </a:pPr>
-            <a:r>
-              <a:rPr lang="en-US" sz="1000" dirty="0">
-                <a:solidFill>
-                  <a:srgbClr val="6B7B8D"/>
-                </a:solidFill>
-                <a:latin typeface="Calibri" pitchFamily="34" charset="0"/>
-                <a:ea typeface="Calibri" pitchFamily="34" charset="-122"/>
-                <a:cs typeface="Calibri" pitchFamily="34" charset="-120"/>
-              </a:rPr>
-              <a:t>Thai-speaking individuals seeking to manage weight,</a:t>
-            </a:r>
-            <a:endParaRPr lang="en-US" sz="1000" dirty="0"/>
-          </a:p>
-          <a:p>
-            <a:pPr marL="0" indent="0">
-              <a:buNone/>
-            </a:pPr>
-            <a:r>
-              <a:rPr lang="en-US" sz="1000" dirty="0">
-                <a:solidFill>
-                  <a:srgbClr val="6B7B8D"/>
-                </a:solidFill>
-                <a:latin typeface="Calibri" pitchFamily="34" charset="0"/>
-                <a:ea typeface="Calibri" pitchFamily="34" charset="-122"/>
-                <a:cs typeface="Calibri" pitchFamily="34" charset="-120"/>
-              </a:rPr>
-              <a:t>track nutrition, and receive AI-powered dietary coaching.</a:t>
-            </a:r>
-            <a:endParaRPr lang="en-US" sz="1000" dirty="0"/>
-          </a:p>
-          <a:p>
-            <a:pPr marL="0" indent="0">
-              <a:buNone/>
-            </a:pPr>
-            <a:r>
-              <a:rPr lang="en-US" sz="1000" dirty="0">
-                <a:solidFill>
-                  <a:srgbClr val="6B7B8D"/>
-                </a:solidFill>
-                <a:latin typeface="Calibri" pitchFamily="34" charset="0"/>
-                <a:ea typeface="Calibri" pitchFamily="34" charset="-122"/>
-                <a:cs typeface="Calibri" pitchFamily="34" charset="-120"/>
-              </a:rPr>
-              <a:t>Primary: health-conscious adults (18-45 years)</a:t>
-            </a:r>
-            <a:endParaRPr lang="en-US" sz="1000" dirty="0"/>
-          </a:p>
-          <a:p>
-            <a:pPr marL="0" indent="0">
-              <a:buNone/>
-            </a:pPr>
-            <a:r>
-              <a:rPr lang="en-US" sz="1000" dirty="0">
-                <a:solidFill>
-                  <a:srgbClr val="6B7B8D"/>
-                </a:solidFill>
-                <a:latin typeface="Calibri" pitchFamily="34" charset="0"/>
-                <a:ea typeface="Calibri" pitchFamily="34" charset="-122"/>
-                <a:cs typeface="Calibri" pitchFamily="34" charset="-120"/>
-              </a:rPr>
-              <a:t>Secondary: fitness enthusiasts, mild obesity management</a:t>
-            </a:r>
             <a:endParaRPr lang="en-US" sz="1000" dirty="0"/>
           </a:p>
         </p:txBody>

</xml_diff>